<commit_message>
BigOrange: v2 humanized copy across all PDFs and deck, plus Brand Voice Guide
Rewrite every blog, the growth plan and the Thursday deck into the BigOrange
voice with facts, titles, slugs, metadata and numbers locked; add the
standalone Brand Voice Guide PDF and its markdown source.

Co-Authored-By: Claude Fable 5.1 <noreply@anthropic.com>
Claude-Session: https://claude.ai/code/session_013mzRPkHbxBiBbyeHnPghzv
</commit_message>
<xml_diff>
--- a/clients/bigorange-marketing/deliverables/2026-09-02-wordpress-growth-package-redesign/BigOrange-Thursday-WordPress-Growth-Review-2026-09-03.pptx
+++ b/clients/bigorange-marketing/deliverables/2026-09-02-wordpress-growth-package-redesign/BigOrange-Thursday-WordPress-Growth-Review-2026-09-03.pptx
@@ -516,7 +516,7 @@
           <a:p>
             <a:r>
               <a:rPr lang="en-US" dirty="0"/>
-              <a:t>Open with the decision: this is a controlled growth system, not a publish-everything content dump.
+              <a:t>Start with the headline: this is a controlled system, not a dump-everything content push.
 [Sources]
 Internal BigOrange working package; September 2, 2026.
 [/Sources]</a:t>
@@ -607,7 +607,7 @@
           <a:p>
             <a:r>
               <a:rPr lang="en-US" dirty="0"/>
-              <a:t>All five are complete standalone articles, not sections of one article.
+              <a:t>Each of these five stands alone, not a chapter of one bigger article.
 [Sources]
 Five-blog package manifest dated September 2, 2026.
 [/Sources]</a:t>
@@ -698,7 +698,7 @@
           <a:p>
             <a:r>
               <a:rPr lang="en-US" dirty="0"/>
-              <a:t>Visible usefulness comes first. Schema supports interpretation; it does not manufacture authority.
+              <a:t>Usefulness on the page comes first. Schema just helps machines read it, it doesn’t manufacture authority.
 [Sources]
 Google Search Central: creating helpful, reliable, people-first content.
 Google Search Central: Article structured data.
@@ -790,7 +790,7 @@
           <a:p>
             <a:r>
               <a:rPr lang="en-US" dirty="0"/>
-              <a:t>This is the private WordPress staging gate. Emphasize reversible drafts and explicit approval.
+              <a:t>This is the private staging gate in WordPress. Drafts stay reversible, and approval is explicit.
 [Sources]
 Internal BigOrange working package; September 2, 2026.
 [/Sources]</a:t>
@@ -881,7 +881,7 @@
           <a:p>
             <a:r>
               <a:rPr lang="en-US" dirty="0"/>
-              <a:t>Do not equate a rank or a view with revenue. Preserve the chain.
+              <a:t>Don’t let a rank or a view stand in for revenue. Walk the whole chain.
 [Sources]
 Internal BigOrange working package; September 2, 2026.
 [/Sources]</a:t>
@@ -972,7 +972,7 @@
           <a:p>
             <a:r>
               <a:rPr lang="en-US" dirty="0"/>
-              <a:t>The cadence is deliberately controlled so the team can learn and protect existing rankings.
+              <a:t>We’re pacing this on purpose, so the team can learn and protect what already ranks.
 [Sources]
 Internal BigOrange working package; September 2, 2026.
 [/Sources]</a:t>
@@ -1063,7 +1063,7 @@
           <a:p>
             <a:r>
               <a:rPr lang="en-US" dirty="0"/>
-              <a:t>Close by assigning owners and the first release dates. Keep Phase 2 as a separate commercial decision.
+              <a:t>Close by locking in owners and the first release dates. Keep Phase 2 as its own decision.
 [Sources]
 Internal BigOrange working package; September 2, 2026.
 [/Sources]</a:t>
@@ -1154,7 +1154,7 @@
           <a:p>
             <a:r>
               <a:rPr lang="en-US" dirty="0"/>
-              <a:t>Re-anchor the room in the signed scope before discussing the additional work.
+              <a:t>Ground us in the signed scope first, then get into everything on top of it.
 [Sources]
 Original BigOrange proposal and working packet.
 [/Sources]</a:t>
@@ -1245,7 +1245,7 @@
           <a:p>
             <a:r>
               <a:rPr lang="en-US" dirty="0"/>
-              <a:t>Use the no-charge language exactly as a statement of investment, not as an unlimited ongoing scope.
+              <a:t>Frame the no-charge work as a statement of investment, not an open-ended scope.
 [Sources]
 Internal BigOrange working package; September 2, 2026.
 [/Sources]</a:t>
@@ -1336,7 +1336,7 @@
           <a:p>
             <a:r>
               <a:rPr lang="en-US" dirty="0"/>
-              <a:t>Make the governance boundary explicit. Current public hub remains unchanged.
+              <a:t>Be plain about the line here: what’s live stays live until someone signs off.
 [Sources]
 September 1, 2026 public crawl and WordPress inventory.
 [/Sources]</a:t>
@@ -1427,7 +1427,7 @@
           <a:p>
             <a:r>
               <a:rPr lang="en-US" dirty="0"/>
-              <a:t>These are leverage fixes because they affect interpretation, discovery, rendering or distribution.
+              <a:t>These fixes matter because they change how the site gets read, found, and shown.
 [Sources]
 September 1, 2026 public crawl.
 August 20, 2026 builder hub mobile performance sample.
@@ -1519,7 +1519,7 @@
           <a:p>
             <a:r>
               <a:rPr lang="en-US" dirty="0"/>
-              <a:t>Keep the language disciplined: sample, then remeasure.
+              <a:t>Stay disciplined here: it’s one sample, and we remeasure after the fixes land.
 [Sources]
 August 20, 2026 builder hub mobile performance sample.
 [/Sources]</a:t>
@@ -1610,7 +1610,7 @@
           <a:p>
             <a:r>
               <a:rPr lang="en-US" dirty="0"/>
-              <a:t>Moz is a dated snapshot, not a live ranking guarantee.
+              <a:t>Remember Moz is a snapshot in time, not live rankings.
 [Sources]
 Moz snapshot dated August 14, 2026.
 [/Sources]</a:t>
@@ -1701,7 +1701,7 @@
           <a:p>
             <a:r>
               <a:rPr lang="en-US" dirty="0"/>
-              <a:t>This is the universal release contract. The wording and proof pattern still vary by template.
+              <a:t>This is the release checklist for every page. Wording and proof still differ by template.
 [Sources]
 Google Search Central: creating helpful, reliable, people-first content.
 Google Search Central: Article structured data.
@@ -1793,7 +1793,7 @@
           <a:p>
             <a:r>
               <a:rPr lang="en-US" dirty="0"/>
-              <a:t>Explain that the service page remains the commercial destination while articles answer narrower questions.
+              <a:t>Explain that the service page stays the sales destination, and the articles just answer the narrower questions.
 [Sources]
 BigOrange authority package inventory and internal-link map.
 [/Sources]</a:t>
@@ -2315,7 +2315,7 @@
                 <a:ea typeface="Montserrat" pitchFamily="34" charset="-122"/>
                 <a:cs typeface="Montserrat" pitchFamily="34" charset="-120"/>
               </a:rPr>
-              <a:t>WordPress growth, made operational.</a:t>
+              <a:t>Where your WordPress site stands.</a:t>
             </a:r>
             <a:endParaRPr lang="en-US" sz="5000" dirty="0"/>
           </a:p>
@@ -2354,7 +2354,7 @@
                 <a:ea typeface="Arial" pitchFamily="34" charset="-122"/>
                 <a:cs typeface="Arial" pitchFamily="34" charset="-120"/>
               </a:rPr>
-              <a:t>A 370 URL technical plan, a 24 asset authority system, five new builder blogs, and the release controls that turn content into qualified demand.</a:t>
+              <a:t>A 370 URL technical plan, a 24 asset authority system, five new builder blogs, and the checks that turn content into real leads.</a:t>
             </a:r>
             <a:endParaRPr lang="en-US" sz="1500" dirty="0"/>
           </a:p>
@@ -3936,7 +3936,7 @@
                 <a:ea typeface="Montserrat" pitchFamily="34" charset="-122"/>
                 <a:cs typeface="Montserrat" pitchFamily="34" charset="-120"/>
               </a:rPr>
-              <a:t>What is baked into every blog</a:t>
+              <a:t>What’s built into every blog</a:t>
             </a:r>
             <a:endParaRPr lang="en-US" sz="3000" dirty="0"/>
           </a:p>
@@ -4127,7 +4127,7 @@
                 <a:ea typeface="Arial" pitchFamily="34" charset="-122"/>
                 <a:cs typeface="Arial" pitchFamily="34" charset="-120"/>
               </a:rPr>
-              <a:t>A direct answer, definition and descriptive headings make the page easy for people and machines to parse.</a:t>
+              <a:t>A direct answer, a clear definition and descriptive headings make the page easy to read, for people and machines.</a:t>
             </a:r>
             <a:endParaRPr lang="en-US" sz="1100" dirty="0"/>
           </a:p>
@@ -4318,7 +4318,7 @@
                 <a:ea typeface="Arial" pitchFamily="34" charset="-122"/>
                 <a:cs typeface="Arial" pitchFamily="34" charset="-120"/>
               </a:rPr>
-              <a:t>Tables, steps, tradeoffs and specific review questions create usefulness beyond generic summaries.</a:t>
+              <a:t>Tables, steps, tradeoffs and real review questions make the page more useful than a generic summary.</a:t>
             </a:r>
             <a:endParaRPr lang="en-US" sz="1100" dirty="0"/>
           </a:p>
@@ -4509,7 +4509,7 @@
                 <a:ea typeface="Arial" pitchFamily="34" charset="-122"/>
                 <a:cs typeface="Arial" pitchFamily="34" charset="-120"/>
               </a:rPr>
-              <a:t>Current sources, explicit caveats, named review gates and no invented results or guarantees.</a:t>
+              <a:t>Current sources, clear caveats, named review gates, and never an invented result or guarantee.</a:t>
             </a:r>
             <a:endParaRPr lang="en-US" sz="1100" dirty="0"/>
           </a:p>
@@ -4700,7 +4700,7 @@
                 <a:ea typeface="Arial" pitchFamily="34" charset="-122"/>
                 <a:cs typeface="Arial" pitchFamily="34" charset="-120"/>
               </a:rPr>
-              <a:t>BlogPosting and Breadcrumb candidates mirror visible content. FAQs stay reader-first without a rich-result promise.</a:t>
+              <a:t>BlogPosting and Breadcrumb data mirror what’s on the page. FAQs are written for readers, not for a rich-result promise.</a:t>
             </a:r>
             <a:endParaRPr lang="en-US" sz="1100" dirty="0"/>
           </a:p>
@@ -5977,7 +5977,7 @@
                 <a:ea typeface="Montserrat" pitchFamily="34" charset="-122"/>
                 <a:cs typeface="Montserrat" pitchFamily="34" charset="-120"/>
               </a:rPr>
-              <a:t>No draft enters the sitemap. No public publish occurs without a named release owner.</a:t>
+              <a:t>No draft hits the sitemap. Nothing goes public without a named release owner.</a:t>
             </a:r>
             <a:endParaRPr lang="en-US" sz="1500" dirty="0"/>
           </a:p>
@@ -6214,7 +6214,7 @@
                 <a:ea typeface="Montserrat" pitchFamily="34" charset="-122"/>
                 <a:cs typeface="Montserrat" pitchFamily="34" charset="-120"/>
               </a:rPr>
-              <a:t>Rankings become useful when they connect to sales truth</a:t>
+              <a:t>Rankings only matter once they lead to a sale</a:t>
             </a:r>
             <a:endParaRPr lang="en-US" sz="3000" dirty="0"/>
           </a:p>
@@ -7325,7 +7325,7 @@
                 <a:ea typeface="Montserrat" pitchFamily="34" charset="-122"/>
                 <a:cs typeface="Montserrat" pitchFamily="34" charset="-120"/>
               </a:rPr>
-              <a:t>Repair first. Release in waves. Learn before scaling.</a:t>
+              <a:t>Fix it first. Ship in waves. Learn before scaling.</a:t>
             </a:r>
             <a:endParaRPr lang="en-US" sz="3000" dirty="0"/>
           </a:p>
@@ -7932,7 +7932,7 @@
                 <a:ea typeface="Montserrat" pitchFamily="34" charset="-122"/>
                 <a:cs typeface="Montserrat" pitchFamily="34" charset="-120"/>
               </a:rPr>
-              <a:t>12-month scale: expand only where Search Console, client questions and sales feedback justify the next asset.</a:t>
+              <a:t>12-month scale: we only add more where Search Console, client questions and sales feedback say it’s worth it.</a:t>
             </a:r>
             <a:endParaRPr lang="en-US" sz="1400" dirty="0"/>
           </a:p>
@@ -8169,7 +8169,7 @@
                 <a:ea typeface="Montserrat" pitchFamily="34" charset="-122"/>
                 <a:cs typeface="Montserrat" pitchFamily="34" charset="-120"/>
               </a:rPr>
-              <a:t>Seven decisions that unlock the work</a:t>
+              <a:t>Seven decisions that get this moving</a:t>
             </a:r>
             <a:endParaRPr lang="en-US" sz="3000" dirty="0"/>
           </a:p>
@@ -8954,7 +8954,7 @@
                 <a:ea typeface="Arial" pitchFamily="34" charset="-122"/>
                 <a:cs typeface="Arial" pitchFamily="34" charset="-120"/>
               </a:rPr>
-              <a:t>The goal is a named owner, a release sequence and a measurement contract — not a longer idea list.</a:t>
+              <a:t>The goal is a named owner, a release order and a way to measure it, not a longer idea list.</a:t>
             </a:r>
             <a:endParaRPr lang="en-US" sz="1400" dirty="0"/>
           </a:p>
@@ -9191,7 +9191,7 @@
                 <a:ea typeface="Montserrat" pitchFamily="34" charset="-122"/>
                 <a:cs typeface="Montserrat" pitchFamily="34" charset="-120"/>
               </a:rPr>
-              <a:t>What the paid pilot actually asked for</a:t>
+              <a:t>What we actually agreed to</a:t>
             </a:r>
             <a:endParaRPr lang="en-US" sz="3000" dirty="0"/>
           </a:p>
@@ -9333,7 +9333,7 @@
                 <a:ea typeface="Arial" pitchFamily="34" charset="-122"/>
                 <a:cs typeface="Arial" pitchFamily="34" charset="-120"/>
               </a:rPr>
-              <a:t>Discovery, audit, keyword and content strategy, architecture, priorities and implementation planning.</a:t>
+              <a:t>A full audit, a keyword and content strategy, plus the architecture, priorities and plan for building it.</a:t>
             </a:r>
             <a:endParaRPr lang="en-US" sz="1250" dirty="0"/>
           </a:p>
@@ -9475,7 +9475,7 @@
                 <a:ea typeface="Arial" pitchFamily="34" charset="-122"/>
                 <a:cs typeface="Arial" pitchFamily="34" charset="-120"/>
               </a:rPr>
-              <a:t>One pillar page, two supporting articles, technical SEO and WordPress implementation support.</a:t>
+              <a:t>One pillar page, two supporting articles, and hands-on technical SEO and WordPress help.</a:t>
             </a:r>
             <a:endParaRPr lang="en-US" sz="1250" dirty="0"/>
           </a:p>
@@ -9617,7 +9617,7 @@
                 <a:ea typeface="Arial" pitchFamily="34" charset="-122"/>
                 <a:cs typeface="Arial" pitchFamily="34" charset="-120"/>
               </a:rPr>
-              <a:t>35 hours at $30 per hour. Phase 2 social, downloadable and webinar production remained a future scope, not part of the paid pilot.</a:t>
+              <a:t>35 hours at $30 an hour. Phase 2 social, downloadable and webinar work stayed out of scope for this pilot.</a:t>
             </a:r>
             <a:endParaRPr lang="en-US" sz="1250" dirty="0"/>
           </a:p>
@@ -9854,7 +9854,7 @@
                 <a:ea typeface="Montserrat" pitchFamily="34" charset="-122"/>
                 <a:cs typeface="Montserrat" pitchFamily="34" charset="-120"/>
               </a:rPr>
-              <a:t>What is now ready for review</a:t>
+              <a:t>What is ready for you to look at</a:t>
             </a:r>
             <a:endParaRPr lang="en-US" sz="3000" dirty="0"/>
           </a:p>
@@ -10411,7 +10411,7 @@
                 <a:ea typeface="Arial" pitchFamily="34" charset="-122"/>
                 <a:cs typeface="Arial" pitchFamily="34" charset="-120"/>
               </a:rPr>
-              <a:t>The five new blogs, deeper page-level optimization framework, six branded PDFs, implementation packaging and this leadership deck are included as additional proof of how invested I am in BigOrange and the work you deliver for clients.</a:t>
+              <a:t>The five new blogs, a deeper page-level optimization framework, six branded PDFs, implementation packaging and this leadership deck are all extra, my way of showing how invested I am in BigOrange and the work you do for clients.</a:t>
             </a:r>
             <a:endParaRPr lang="en-US" sz="1200" dirty="0"/>
           </a:p>
@@ -10440,7 +10440,7 @@
                 <a:ea typeface="Arial" pitchFamily="34" charset="-122"/>
                 <a:cs typeface="Arial" pitchFamily="34" charset="-120"/>
               </a:rPr>
-              <a:t>Public release, imagery and factual claims still require BigOrange approval.</a:t>
+              <a:t>Public release, imagery and factual claims still need BigOrange approval.</a:t>
             </a:r>
             <a:endParaRPr lang="en-US" sz="1200" dirty="0"/>
           </a:p>
@@ -10479,7 +10479,7 @@
                 <a:ea typeface="Montserrat" pitchFamily="34" charset="-122"/>
                 <a:cs typeface="Montserrat" pitchFamily="34" charset="-120"/>
               </a:rPr>
-              <a:t>Additional work, delivered at no charge, on top of the signed 35 hour pilot.</a:t>
+              <a:t>Extra work, done at no charge, on top of the signed 35 hour pilot.</a:t>
             </a:r>
             <a:endParaRPr lang="en-US" sz="1800" dirty="0"/>
           </a:p>
@@ -10716,7 +10716,7 @@
                 <a:ea typeface="Montserrat" pitchFamily="34" charset="-122"/>
                 <a:cs typeface="Montserrat" pitchFamily="34" charset="-120"/>
               </a:rPr>
-              <a:t>One system: crawlability, answers, proof and conversion</a:t>
+              <a:t>One site, working start to finish</a:t>
             </a:r>
             <a:endParaRPr lang="en-US" sz="3000" dirty="0"/>
           </a:p>
@@ -11273,7 +11273,7 @@
                 <a:ea typeface="Arial" pitchFamily="34" charset="-122"/>
                 <a:cs typeface="Arial" pitchFamily="34" charset="-120"/>
               </a:rPr>
-              <a:t>The new blogs and collateral are staged for private review. Existing public content stays untouched until a named owner approves facts, images, metadata, links, schema and release timing.</a:t>
+              <a:t>The new blogs and collateral are sitting in private review. What’s live now stays live until a named owner signs off on the facts, images, links, and when it goes out.</a:t>
             </a:r>
             <a:endParaRPr lang="en-US" sz="1250" dirty="0"/>
           </a:p>
@@ -11336,7 +11336,7 @@
                 <a:ea typeface="Montserrat" pitchFamily="34" charset="-122"/>
                 <a:cs typeface="Montserrat" pitchFamily="34" charset="-120"/>
               </a:rPr>
-              <a:t>Current public builder hub remains unchanged.</a:t>
+              <a:t>The builder hub you have live today isn’t touched.</a:t>
             </a:r>
             <a:endParaRPr lang="en-US" sz="1400" dirty="0"/>
           </a:p>
@@ -11573,7 +11573,7 @@
                 <a:ea typeface="Montserrat" pitchFamily="34" charset="-122"/>
                 <a:cs typeface="Montserrat" pitchFamily="34" charset="-120"/>
               </a:rPr>
-              <a:t>Where site health is leaking authority</a:t>
+              <a:t>Where the site is losing ground</a:t>
             </a:r>
             <a:endParaRPr lang="en-US" sz="3000" dirty="0"/>
           </a:p>
@@ -12088,7 +12088,7 @@
                 <a:ea typeface="Montserrat" pitchFamily="34" charset="-122"/>
                 <a:cs typeface="Montserrat" pitchFamily="34" charset="-120"/>
               </a:rPr>
-              <a:t>Correct signals before scaling content</a:t>
+              <a:t>Fix the signals before you scale content</a:t>
             </a:r>
             <a:endParaRPr lang="en-US" sz="1600" dirty="0"/>
           </a:p>
@@ -12130,7 +12130,7 @@
                 <a:ea typeface="Arial" pitchFamily="34" charset="-122"/>
                 <a:cs typeface="Arial" pitchFamily="34" charset="-120"/>
               </a:rPr>
-              <a:t>Fix the homepage “Stategic” typo across meta, Open Graph and schema. Reduce the AI services page from four H1s to one. Review nofollow page by page. Repair sitemap eligibility. Re-test the builder hub mobile critical path after media and script work.</a:t>
+              <a:t>Fix the homepage “Stategic” typo across meta, Open Graph and schema. Cut the AI services page from four H1s to one. Check nofollow page by page. Fix sitemap eligibility. Re-test the builder hub on mobile after the media and script work.</a:t>
             </a:r>
             <a:endParaRPr lang="en-US" sz="1200" dirty="0"/>
           </a:p>
@@ -12193,7 +12193,7 @@
                 <a:ea typeface="Montserrat" pitchFamily="34" charset="-122"/>
                 <a:cs typeface="Montserrat" pitchFamily="34" charset="-120"/>
               </a:rPr>
-              <a:t>These affect interpretation, discovery, rendering or distribution.</a:t>
+              <a:t>These change how the site gets read, found, and shown.</a:t>
             </a:r>
             <a:endParaRPr lang="en-US" sz="1400" dirty="0"/>
           </a:p>
@@ -12430,7 +12430,7 @@
                 <a:ea typeface="Montserrat" pitchFamily="34" charset="-122"/>
                 <a:cs typeface="Montserrat" pitchFamily="34" charset="-120"/>
               </a:rPr>
-              <a:t>The builder hub has a performance problem, not a cosmetic one</a:t>
+              <a:t>The builder hub is slow, and that matters</a:t>
             </a:r>
             <a:endParaRPr lang="en-US" sz="3000" dirty="0"/>
           </a:p>
@@ -12699,7 +12699,7 @@
                 <a:ea typeface="Arial" pitchFamily="34" charset="-122"/>
                 <a:cs typeface="Arial" pitchFamily="34" charset="-120"/>
               </a:rPr>
-              <a:t>Re-measure after image sizing, format, preload, font, third-party script and critical CSS work. A single sample is a diagnostic baseline, not a permanent score.</a:t>
+              <a:t>We’ll re-test after fixing image sizing, formats, preload, fonts, third-party scripts and critical CSS. One sample is a starting point, not a final grade.</a:t>
             </a:r>
             <a:endParaRPr lang="en-US" sz="1400" dirty="0"/>
           </a:p>
@@ -13493,7 +13493,7 @@
                 <a:ea typeface="Arial" pitchFamily="34" charset="-122"/>
                 <a:cs typeface="Arial" pitchFamily="34" charset="-120"/>
               </a:rPr>
-              <a:t>Thirteen builder terms are already in positions 1–3, all pointing to the builder hub. That page remains the commercial owner.</a:t>
+              <a:t>Thirteen builder terms already sit in positions 1–3, all pointing to the builder hub. That page stays the one that sells.</a:t>
             </a:r>
             <a:endParaRPr lang="en-US" sz="1050" dirty="0"/>
           </a:p>
@@ -13875,7 +13875,7 @@
                 <a:ea typeface="Montserrat" pitchFamily="34" charset="-122"/>
                 <a:cs typeface="Montserrat" pitchFamily="34" charset="-120"/>
               </a:rPr>
-              <a:t>The page contract: ten layers, one accountable owner</a:t>
+              <a:t>One page, ten checks, one owner</a:t>
             </a:r>
             <a:endParaRPr lang="en-US" sz="3000" dirty="0"/>
           </a:p>
@@ -15532,7 +15532,7 @@
                 <a:ea typeface="Montserrat" pitchFamily="34" charset="-122"/>
                 <a:cs typeface="Montserrat" pitchFamily="34" charset="-120"/>
               </a:rPr>
-              <a:t>24 assets should behave like one system</a:t>
+              <a:t>24 assets, working like one system</a:t>
             </a:r>
             <a:endParaRPr lang="en-US" sz="3000" dirty="0"/>
           </a:p>
@@ -16058,7 +16058,7 @@
                 <a:ea typeface="Montserrat" pitchFamily="34" charset="-122"/>
                 <a:cs typeface="Montserrat" pitchFamily="34" charset="-120"/>
               </a:rPr>
-              <a:t>Parent ownership prevents cannibalization. Contextual links move readers toward the right answer and the right next step.</a:t>
+              <a:t>One page owns each topic, so pages stop competing with each other. Links guide readers to the right answer, then the next step.</a:t>
             </a:r>
             <a:endParaRPr lang="en-US" sz="1600" dirty="0"/>
           </a:p>

</xml_diff>